<commit_message>
sideband and PT generation
</commit_message>
<xml_diff>
--- a/frequency distribution.pptx
+++ b/frequency distribution.pptx
@@ -7308,8 +7308,8 @@
           </a:p>
         </p:txBody>
       </p:sp>
-      <mc:AlternateContent xmlns:mc="http://schemas.openxmlformats.org/markup-compatibility/2006">
-        <mc:Choice xmlns:a14="http://schemas.microsoft.com/office/drawing/2010/main" Requires="a14">
+      <mc:AlternateContent xmlns:mc="http://schemas.openxmlformats.org/markup-compatibility/2006" xmlns:a14="http://schemas.microsoft.com/office/drawing/2010/main">
+        <mc:Choice Requires="a14">
           <p:sp>
             <p:nvSpPr>
               <p:cNvPr id="7" name="TextBox 6">
@@ -7396,7 +7396,7 @@
             </p:txBody>
           </p:sp>
         </mc:Choice>
-        <mc:Fallback>
+        <mc:Fallback xmlns="">
           <p:sp>
             <p:nvSpPr>
               <p:cNvPr id="7" name="TextBox 6">
@@ -7441,8 +7441,8 @@
           </p:sp>
         </mc:Fallback>
       </mc:AlternateContent>
-      <mc:AlternateContent xmlns:mc="http://schemas.openxmlformats.org/markup-compatibility/2006">
-        <mc:Choice xmlns:a14="http://schemas.microsoft.com/office/drawing/2010/main" Requires="a14">
+      <mc:AlternateContent xmlns:mc="http://schemas.openxmlformats.org/markup-compatibility/2006" xmlns:a14="http://schemas.microsoft.com/office/drawing/2010/main">
+        <mc:Choice Requires="a14">
           <p:sp>
             <p:nvSpPr>
               <p:cNvPr id="36" name="TextBox 35">
@@ -7559,7 +7559,7 @@
             </p:txBody>
           </p:sp>
         </mc:Choice>
-        <mc:Fallback>
+        <mc:Fallback xmlns="">
           <p:sp>
             <p:nvSpPr>
               <p:cNvPr id="36" name="TextBox 35">
@@ -7721,8 +7721,8 @@
           </a:p>
         </p:txBody>
       </p:sp>
-      <mc:AlternateContent xmlns:mc="http://schemas.openxmlformats.org/markup-compatibility/2006">
-        <mc:Choice xmlns:a14="http://schemas.microsoft.com/office/drawing/2010/main" Requires="a14">
+      <mc:AlternateContent xmlns:mc="http://schemas.openxmlformats.org/markup-compatibility/2006" xmlns:a14="http://schemas.microsoft.com/office/drawing/2010/main">
+        <mc:Choice Requires="a14">
           <p:sp>
             <p:nvSpPr>
               <p:cNvPr id="39" name="TextBox 38">
@@ -7839,7 +7839,7 @@
             </p:txBody>
           </p:sp>
         </mc:Choice>
-        <mc:Fallback>
+        <mc:Fallback xmlns="">
           <p:sp>
             <p:nvSpPr>
               <p:cNvPr id="39" name="TextBox 38">
@@ -7884,8 +7884,8 @@
           </p:sp>
         </mc:Fallback>
       </mc:AlternateContent>
-      <mc:AlternateContent xmlns:mc="http://schemas.openxmlformats.org/markup-compatibility/2006">
-        <mc:Choice xmlns:a14="http://schemas.microsoft.com/office/drawing/2010/main" Requires="a14">
+      <mc:AlternateContent xmlns:mc="http://schemas.openxmlformats.org/markup-compatibility/2006" xmlns:a14="http://schemas.microsoft.com/office/drawing/2010/main">
+        <mc:Choice Requires="a14">
           <p:sp>
             <p:nvSpPr>
               <p:cNvPr id="40" name="TextBox 39">
@@ -8002,7 +8002,7 @@
             </p:txBody>
           </p:sp>
         </mc:Choice>
-        <mc:Fallback>
+        <mc:Fallback xmlns="">
           <p:sp>
             <p:nvSpPr>
               <p:cNvPr id="40" name="TextBox 39">
@@ -8047,8 +8047,8 @@
           </p:sp>
         </mc:Fallback>
       </mc:AlternateContent>
-      <mc:AlternateContent xmlns:mc="http://schemas.openxmlformats.org/markup-compatibility/2006">
-        <mc:Choice xmlns:a14="http://schemas.microsoft.com/office/drawing/2010/main" Requires="a14">
+      <mc:AlternateContent xmlns:mc="http://schemas.openxmlformats.org/markup-compatibility/2006" xmlns:a14="http://schemas.microsoft.com/office/drawing/2010/main">
+        <mc:Choice Requires="a14">
           <p:sp>
             <p:nvSpPr>
               <p:cNvPr id="43" name="TextBox 42">
@@ -8192,7 +8192,7 @@
             </p:txBody>
           </p:sp>
         </mc:Choice>
-        <mc:Fallback>
+        <mc:Fallback xmlns="">
           <p:sp>
             <p:nvSpPr>
               <p:cNvPr id="43" name="TextBox 42">
@@ -8237,8 +8237,8 @@
           </p:sp>
         </mc:Fallback>
       </mc:AlternateContent>
-      <mc:AlternateContent xmlns:mc="http://schemas.openxmlformats.org/markup-compatibility/2006">
-        <mc:Choice xmlns:a14="http://schemas.microsoft.com/office/drawing/2010/main" Requires="a14">
+      <mc:AlternateContent xmlns:mc="http://schemas.openxmlformats.org/markup-compatibility/2006" xmlns:a14="http://schemas.microsoft.com/office/drawing/2010/main">
+        <mc:Choice Requires="a14">
           <p:sp>
             <p:nvSpPr>
               <p:cNvPr id="44" name="TextBox 43">
@@ -8355,7 +8355,7 @@
             </p:txBody>
           </p:sp>
         </mc:Choice>
-        <mc:Fallback>
+        <mc:Fallback xmlns="">
           <p:sp>
             <p:nvSpPr>
               <p:cNvPr id="44" name="TextBox 43">
@@ -8400,8 +8400,8 @@
           </p:sp>
         </mc:Fallback>
       </mc:AlternateContent>
-      <mc:AlternateContent xmlns:mc="http://schemas.openxmlformats.org/markup-compatibility/2006">
-        <mc:Choice xmlns:a14="http://schemas.microsoft.com/office/drawing/2010/main" Requires="a14">
+      <mc:AlternateContent xmlns:mc="http://schemas.openxmlformats.org/markup-compatibility/2006" xmlns:a14="http://schemas.microsoft.com/office/drawing/2010/main">
+        <mc:Choice Requires="a14">
           <p:sp>
             <p:nvSpPr>
               <p:cNvPr id="46" name="TextBox 45">
@@ -8545,7 +8545,7 @@
             </p:txBody>
           </p:sp>
         </mc:Choice>
-        <mc:Fallback>
+        <mc:Fallback xmlns="">
           <p:sp>
             <p:nvSpPr>
               <p:cNvPr id="46" name="TextBox 45">
@@ -8590,8 +8590,8 @@
           </p:sp>
         </mc:Fallback>
       </mc:AlternateContent>
-      <mc:AlternateContent xmlns:mc="http://schemas.openxmlformats.org/markup-compatibility/2006">
-        <mc:Choice xmlns:a14="http://schemas.microsoft.com/office/drawing/2010/main" Requires="a14">
+      <mc:AlternateContent xmlns:mc="http://schemas.openxmlformats.org/markup-compatibility/2006" xmlns:a14="http://schemas.microsoft.com/office/drawing/2010/main">
+        <mc:Choice Requires="a14">
           <p:sp>
             <p:nvSpPr>
               <p:cNvPr id="54" name="TextBox 53">
@@ -8708,7 +8708,7 @@
             </p:txBody>
           </p:sp>
         </mc:Choice>
-        <mc:Fallback>
+        <mc:Fallback xmlns="">
           <p:sp>
             <p:nvSpPr>
               <p:cNvPr id="54" name="TextBox 53">
@@ -8753,8 +8753,8 @@
           </p:sp>
         </mc:Fallback>
       </mc:AlternateContent>
-      <mc:AlternateContent xmlns:mc="http://schemas.openxmlformats.org/markup-compatibility/2006">
-        <mc:Choice xmlns:a14="http://schemas.microsoft.com/office/drawing/2010/main" Requires="a14">
+      <mc:AlternateContent xmlns:mc="http://schemas.openxmlformats.org/markup-compatibility/2006" xmlns:a14="http://schemas.microsoft.com/office/drawing/2010/main">
+        <mc:Choice Requires="a14">
           <p:sp>
             <p:nvSpPr>
               <p:cNvPr id="57" name="TextBox 56">
@@ -8871,7 +8871,7 @@
             </p:txBody>
           </p:sp>
         </mc:Choice>
-        <mc:Fallback>
+        <mc:Fallback xmlns="">
           <p:sp>
             <p:nvSpPr>
               <p:cNvPr id="57" name="TextBox 56">
@@ -8964,8 +8964,8 @@
           </a:fontRef>
         </p:style>
       </p:cxnSp>
-      <mc:AlternateContent xmlns:mc="http://schemas.openxmlformats.org/markup-compatibility/2006">
-        <mc:Choice xmlns:a14="http://schemas.microsoft.com/office/drawing/2010/main" Requires="a14">
+      <mc:AlternateContent xmlns:mc="http://schemas.openxmlformats.org/markup-compatibility/2006" xmlns:a14="http://schemas.microsoft.com/office/drawing/2010/main">
+        <mc:Choice Requires="a14">
           <p:sp>
             <p:nvSpPr>
               <p:cNvPr id="59" name="TextBox 58">
@@ -9082,7 +9082,7 @@
             </p:txBody>
           </p:sp>
         </mc:Choice>
-        <mc:Fallback>
+        <mc:Fallback xmlns="">
           <p:sp>
             <p:nvSpPr>
               <p:cNvPr id="59" name="TextBox 58">
@@ -9228,8 +9228,12 @@
           <a:lstStyle/>
           <a:p>
             <a:r>
+              <a:rPr lang="en-US"/>
+              <a:t>miniLISA</a:t>
+            </a:r>
+            <a:r>
               <a:rPr lang="en-US" dirty="0"/>
-              <a:t>LISA Timing Jitters</a:t>
+              <a:t> Timing Jitters</a:t>
             </a:r>
             <a:endParaRPr lang="LID4096" dirty="0"/>
           </a:p>
@@ -9886,8 +9890,8 @@
           </a:p>
         </p:txBody>
       </p:sp>
-      <mc:AlternateContent xmlns:mc="http://schemas.openxmlformats.org/markup-compatibility/2006">
-        <mc:Choice xmlns:a14="http://schemas.microsoft.com/office/drawing/2010/main" Requires="a14">
+      <mc:AlternateContent xmlns:mc="http://schemas.openxmlformats.org/markup-compatibility/2006" xmlns:a14="http://schemas.microsoft.com/office/drawing/2010/main">
+        <mc:Choice Requires="a14">
           <p:sp>
             <p:nvSpPr>
               <p:cNvPr id="40" name="TextBox 39">
@@ -10004,7 +10008,7 @@
             </p:txBody>
           </p:sp>
         </mc:Choice>
-        <mc:Fallback>
+        <mc:Fallback xmlns="">
           <p:sp>
             <p:nvSpPr>
               <p:cNvPr id="40" name="TextBox 39">
@@ -10097,8 +10101,8 @@
           </a:fontRef>
         </p:style>
       </p:cxnSp>
-      <mc:AlternateContent xmlns:mc="http://schemas.openxmlformats.org/markup-compatibility/2006">
-        <mc:Choice xmlns:a14="http://schemas.microsoft.com/office/drawing/2010/main" Requires="a14">
+      <mc:AlternateContent xmlns:mc="http://schemas.openxmlformats.org/markup-compatibility/2006" xmlns:a14="http://schemas.microsoft.com/office/drawing/2010/main">
+        <mc:Choice Requires="a14">
           <p:sp>
             <p:nvSpPr>
               <p:cNvPr id="58" name="TextBox 57">
@@ -10215,7 +10219,7 @@
             </p:txBody>
           </p:sp>
         </mc:Choice>
-        <mc:Fallback>
+        <mc:Fallback xmlns="">
           <p:sp>
             <p:nvSpPr>
               <p:cNvPr id="58" name="TextBox 57">
@@ -10515,8 +10519,8 @@
           </a:p>
         </p:txBody>
       </p:sp>
-      <mc:AlternateContent xmlns:mc="http://schemas.openxmlformats.org/markup-compatibility/2006">
-        <mc:Choice xmlns:a14="http://schemas.microsoft.com/office/drawing/2010/main" Requires="a14">
+      <mc:AlternateContent xmlns:mc="http://schemas.openxmlformats.org/markup-compatibility/2006" xmlns:a14="http://schemas.microsoft.com/office/drawing/2010/main">
+        <mc:Choice Requires="a14">
           <p:sp>
             <p:nvSpPr>
               <p:cNvPr id="7" name="TextBox 6">
@@ -10545,6 +10549,7 @@
               </a:bodyPr>
               <a:lstStyle/>
               <a:p>
+                <a:pPr/>
                 <a14:m>
                   <m:oMathPara xmlns:m="http://schemas.openxmlformats.org/officeDocument/2006/math">
                     <m:oMathParaPr>
@@ -10763,7 +10768,7 @@
             </p:txBody>
           </p:sp>
         </mc:Choice>
-        <mc:Fallback>
+        <mc:Fallback xmlns="">
           <p:sp>
             <p:nvSpPr>
               <p:cNvPr id="7" name="TextBox 6">
@@ -10808,8 +10813,8 @@
           </p:sp>
         </mc:Fallback>
       </mc:AlternateContent>
-      <mc:AlternateContent xmlns:mc="http://schemas.openxmlformats.org/markup-compatibility/2006">
-        <mc:Choice xmlns:a14="http://schemas.microsoft.com/office/drawing/2010/main" Requires="a14">
+      <mc:AlternateContent xmlns:mc="http://schemas.openxmlformats.org/markup-compatibility/2006" xmlns:a14="http://schemas.microsoft.com/office/drawing/2010/main">
+        <mc:Choice Requires="a14">
           <p:sp>
             <p:nvSpPr>
               <p:cNvPr id="10" name="TextBox 9">
@@ -10838,6 +10843,7 @@
               </a:bodyPr>
               <a:lstStyle/>
               <a:p>
+                <a:pPr/>
                 <a14:m>
                   <m:oMathPara xmlns:m="http://schemas.openxmlformats.org/officeDocument/2006/math">
                     <m:oMathParaPr>
@@ -11096,7 +11102,7 @@
             </p:txBody>
           </p:sp>
         </mc:Choice>
-        <mc:Fallback>
+        <mc:Fallback xmlns="">
           <p:sp>
             <p:nvSpPr>
               <p:cNvPr id="10" name="TextBox 9">
@@ -11141,8 +11147,8 @@
           </p:sp>
         </mc:Fallback>
       </mc:AlternateContent>
-      <mc:AlternateContent xmlns:mc="http://schemas.openxmlformats.org/markup-compatibility/2006">
-        <mc:Choice xmlns:a14="http://schemas.microsoft.com/office/drawing/2010/main" Requires="a14">
+      <mc:AlternateContent xmlns:mc="http://schemas.openxmlformats.org/markup-compatibility/2006" xmlns:a14="http://schemas.microsoft.com/office/drawing/2010/main">
+        <mc:Choice Requires="a14">
           <p:sp>
             <p:nvSpPr>
               <p:cNvPr id="11" name="TextBox 10">
@@ -11171,6 +11177,7 @@
               </a:bodyPr>
               <a:lstStyle/>
               <a:p>
+                <a:pPr/>
                 <a14:m>
                   <m:oMathPara xmlns:m="http://schemas.openxmlformats.org/officeDocument/2006/math">
                     <m:oMathParaPr>
@@ -11381,7 +11388,7 @@
             </p:txBody>
           </p:sp>
         </mc:Choice>
-        <mc:Fallback>
+        <mc:Fallback xmlns="">
           <p:sp>
             <p:nvSpPr>
               <p:cNvPr id="11" name="TextBox 10">
@@ -11426,8 +11433,8 @@
           </p:sp>
         </mc:Fallback>
       </mc:AlternateContent>
-      <mc:AlternateContent xmlns:mc="http://schemas.openxmlformats.org/markup-compatibility/2006">
-        <mc:Choice xmlns:a14="http://schemas.microsoft.com/office/drawing/2010/main" Requires="a14">
+      <mc:AlternateContent xmlns:mc="http://schemas.openxmlformats.org/markup-compatibility/2006" xmlns:a14="http://schemas.microsoft.com/office/drawing/2010/main">
+        <mc:Choice Requires="a14">
           <p:sp>
             <p:nvSpPr>
               <p:cNvPr id="12" name="TextBox 11">
@@ -11456,6 +11463,7 @@
               </a:bodyPr>
               <a:lstStyle/>
               <a:p>
+                <a:pPr/>
                 <a14:m>
                   <m:oMathPara xmlns:m="http://schemas.openxmlformats.org/officeDocument/2006/math">
                     <m:oMathParaPr>
@@ -11693,7 +11701,7 @@
             </p:txBody>
           </p:sp>
         </mc:Choice>
-        <mc:Fallback>
+        <mc:Fallback xmlns="">
           <p:sp>
             <p:nvSpPr>
               <p:cNvPr id="12" name="TextBox 11">

</xml_diff>